<commit_message>
Implement chunked-audio buffer with bounded batching for Task 2 ASR
- Add split_audio() and cleanup_chunks() helpers in app/utils.py for
  fixed-duration (<=30s) WAV chunk generation via pydub
- Refactor transcribe_with_buffer() in app/asr_pipeline.py to process all
  chunks via bounded batches; long audio is no longer truncated at the
  queue capacity of 10
- Add TestAudioSplitting (4 tests) and TestChunkBatching (1 mock test)
  in test_pipeline.py; total unit test count is now 20
- Add pydub>=0.25.1 to task2 requirements.txt
- Update task2 README, project1/2 summary PDFs, system_architecture.png,
  buffer_flow_diagram.png, and final_presentation.pptx to reflect the
  new chunked-audio architecture and 20-test count
</commit_message>
<xml_diff>
--- a/presentation/final_presentation.pptx
+++ b/presentation/final_presentation.pptx
@@ -254,7 +254,7 @@
   </p:defaultTextStyle>
   <p:extLst>
     <p:ext uri="GoogleSlidesCustomDataVersion2">
-      <go:slidesCustomData xmlns:go="http://customooxmlschemas.google.com/" r:id="rId18" roundtripDataSignature="AMtx7mi8IJxB6RxiGNv/kwhRfxyEZhnhIg=="/>
+      <go:slidesCustomData xmlns:go="http://customooxmlschemas.google.com/" r:id="rId18" roundtripDataSignature="AMtx7mhji3cBOZXpgoR+pvRMwLr9rCQ+Sw=="/>
     </p:ext>
   </p:extLst>
 </p:presentation>
@@ -5622,7 +5622,7 @@
         </p:nvSpPr>
         <p:spPr>
           <a:xfrm>
-            <a:off x="6383017" y="1411242"/>
+            <a:off x="6383017" y="1389040"/>
             <a:ext cx="1880400" cy="558300"/>
           </a:xfrm>
           <a:prstGeom prst="rect">
@@ -5654,6 +5654,18 @@
               <a:buNone/>
             </a:pPr>
             <a:r>
+              <a:rPr b="1" lang="en-US" sz="4000">
+                <a:solidFill>
+                  <a:srgbClr val="FFFFFF"/>
+                </a:solidFill>
+                <a:latin typeface="Calibri"/>
+                <a:ea typeface="Calibri"/>
+                <a:cs typeface="Calibri"/>
+                <a:sym typeface="Calibri"/>
+              </a:rPr>
+              <a:t>20</a:t>
+            </a:r>
+            <a:r>
               <a:rPr b="1" i="0" lang="en-US" sz="4000" u="none" cap="none" strike="noStrike">
                 <a:solidFill>
                   <a:srgbClr val="FFFFFF"/>
@@ -5663,7 +5675,19 @@
                 <a:cs typeface="Calibri"/>
                 <a:sym typeface="Calibri"/>
               </a:rPr>
-              <a:t>15 / 15</a:t>
+              <a:t> / </a:t>
+            </a:r>
+            <a:r>
+              <a:rPr b="1" lang="en-US" sz="4000">
+                <a:solidFill>
+                  <a:srgbClr val="FFFFFF"/>
+                </a:solidFill>
+                <a:latin typeface="Calibri"/>
+                <a:ea typeface="Calibri"/>
+                <a:cs typeface="Calibri"/>
+                <a:sym typeface="Calibri"/>
+              </a:rPr>
+              <a:t>20</a:t>
             </a:r>
             <a:endParaRPr b="0" i="0" sz="4000" u="none" cap="none" strike="noStrike">
               <a:solidFill>
@@ -5685,7 +5709,7 @@
         </p:nvSpPr>
         <p:spPr>
           <a:xfrm>
-            <a:off x="6494256" y="2043031"/>
+            <a:off x="6494256" y="2028230"/>
             <a:ext cx="1590000" cy="258900"/>
           </a:xfrm>
           <a:prstGeom prst="rect">
@@ -5748,8 +5772,8 @@
         </p:nvSpPr>
         <p:spPr>
           <a:xfrm>
-            <a:off x="6032100" y="2405003"/>
-            <a:ext cx="2566200" cy="2272200"/>
+            <a:off x="6032100" y="2360596"/>
+            <a:ext cx="2566200" cy="2383200"/>
           </a:xfrm>
           <a:prstGeom prst="rect">
             <a:avLst/>
@@ -5802,26 +5826,6 @@
                 <a:sym typeface="Calibri"/>
               </a:rPr>
             </a:br>
-            <a:endParaRPr b="0" i="0" sz="900" u="none" cap="none" strike="noStrike">
-              <a:solidFill>
-                <a:schemeClr val="dk1"/>
-              </a:solidFill>
-              <a:latin typeface="Calibri"/>
-              <a:ea typeface="Calibri"/>
-              <a:cs typeface="Calibri"/>
-              <a:sym typeface="Calibri"/>
-            </a:endParaRPr>
-          </a:p>
-          <a:p>
-            <a:pPr indent="0" lvl="0" marL="0" marR="0" rtl="0" algn="l">
-              <a:spcBef>
-                <a:spcPts val="0"/>
-              </a:spcBef>
-              <a:spcAft>
-                <a:spcPts val="0"/>
-              </a:spcAft>
-              <a:buNone/>
-            </a:pPr>
             <a:r>
               <a:rPr b="0" i="0" lang="en-US" sz="900" u="none" cap="none" strike="noStrike">
                 <a:solidFill>
@@ -5834,7 +5838,19 @@
               </a:rPr>
               <a:t>6 tests — add, get, full,</a:t>
             </a:r>
-            <a:br>
+            <a:r>
+              <a:rPr lang="en-US" sz="900">
+                <a:solidFill>
+                  <a:srgbClr val="FFFFFF"/>
+                </a:solidFill>
+                <a:latin typeface="Calibri"/>
+                <a:ea typeface="Calibri"/>
+                <a:cs typeface="Calibri"/>
+                <a:sym typeface="Calibri"/>
+              </a:rPr>
+              <a:t> </a:t>
+            </a:r>
+            <a:r>
               <a:rPr b="0" i="0" lang="en-US" sz="900" u="none" cap="none" strike="noStrike">
                 <a:solidFill>
                   <a:srgbClr val="FFFFFF"/>
@@ -5844,30 +5860,8 @@
                 <a:cs typeface="Calibri"/>
                 <a:sym typeface="Calibri"/>
               </a:rPr>
-            </a:br>
-            <a:r>
-              <a:rPr b="0" i="0" lang="en-US" sz="900" u="none" cap="none" strike="noStrike">
-                <a:solidFill>
-                  <a:srgbClr val="FFFFFF"/>
-                </a:solidFill>
-                <a:latin typeface="Calibri"/>
-                <a:ea typeface="Calibri"/>
-                <a:cs typeface="Calibri"/>
-                <a:sym typeface="Calibri"/>
-              </a:rPr>
               <a:t>empty, clear, process_all</a:t>
             </a:r>
-            <a:br>
-              <a:rPr b="0" i="0" lang="en-US" sz="900" u="none" cap="none" strike="noStrike">
-                <a:solidFill>
-                  <a:srgbClr val="FFFFFF"/>
-                </a:solidFill>
-                <a:latin typeface="Calibri"/>
-                <a:ea typeface="Calibri"/>
-                <a:cs typeface="Calibri"/>
-                <a:sym typeface="Calibri"/>
-              </a:rPr>
-            </a:br>
             <a:br>
               <a:rPr b="0" i="0" lang="en-US" sz="900" u="none" cap="none" strike="noStrike">
                 <a:solidFill>
@@ -5916,8 +5910,93 @@
               </a:rPr>
               <a:t>Transliteration Pipeline</a:t>
             </a:r>
+            <a:endParaRPr b="0" i="0" sz="900" u="none" cap="none" strike="noStrike">
+              <a:solidFill>
+                <a:schemeClr val="dk1"/>
+              </a:solidFill>
+              <a:latin typeface="Calibri"/>
+              <a:ea typeface="Calibri"/>
+              <a:cs typeface="Calibri"/>
+              <a:sym typeface="Calibri"/>
+            </a:endParaRPr>
+          </a:p>
+          <a:p>
+            <a:pPr indent="0" lvl="0" marL="0" marR="0" rtl="0" algn="l">
+              <a:spcBef>
+                <a:spcPts val="0"/>
+              </a:spcBef>
+              <a:spcAft>
+                <a:spcPts val="0"/>
+              </a:spcAft>
+              <a:buClr>
+                <a:srgbClr val="FFFFFF"/>
+              </a:buClr>
+              <a:buSzPts val="900"/>
+              <a:buFont typeface="Calibri"/>
+              <a:buNone/>
+            </a:pPr>
+            <a:r>
+              <a:rPr b="0" i="0" lang="en-US" sz="900" u="none" cap="none" strike="noStrike">
+                <a:solidFill>
+                  <a:srgbClr val="FFFFFF"/>
+                </a:solidFill>
+                <a:latin typeface="Calibri"/>
+                <a:ea typeface="Calibri"/>
+                <a:cs typeface="Calibri"/>
+                <a:sym typeface="Calibri"/>
+              </a:rPr>
+              <a:t>4 tests </a:t>
+            </a:r>
+            <a:r>
+              <a:rPr b="0" i="0" lang="en-US" sz="900" u="none" cap="none" strike="noStrike">
+                <a:solidFill>
+                  <a:srgbClr val="FFFFFF"/>
+                </a:solidFill>
+                <a:latin typeface="Calibri"/>
+                <a:ea typeface="Calibri"/>
+                <a:cs typeface="Calibri"/>
+                <a:sym typeface="Calibri"/>
+              </a:rPr>
+              <a:t>—</a:t>
+            </a:r>
+            <a:r>
+              <a:rPr b="0" i="0" lang="en-US" sz="900" u="none" cap="none" strike="noStrike">
+                <a:solidFill>
+                  <a:srgbClr val="FFFFFF"/>
+                </a:solidFill>
+                <a:latin typeface="Calibri"/>
+                <a:ea typeface="Calibri"/>
+                <a:cs typeface="Calibri"/>
+                <a:sym typeface="Calibri"/>
+              </a:rPr>
+              <a:t> basic, empty,</a:t>
+            </a:r>
+            <a:r>
+              <a:rPr lang="en-US" sz="900">
+                <a:solidFill>
+                  <a:srgbClr val="FFFFFF"/>
+                </a:solidFill>
+                <a:latin typeface="Calibri"/>
+                <a:ea typeface="Calibri"/>
+                <a:cs typeface="Calibri"/>
+                <a:sym typeface="Calibri"/>
+              </a:rPr>
+              <a:t> </a:t>
+            </a:r>
+            <a:r>
+              <a:rPr b="0" i="0" lang="en-US" sz="900" u="none" cap="none" strike="noStrike">
+                <a:solidFill>
+                  <a:srgbClr val="FFFFFF"/>
+                </a:solidFill>
+                <a:latin typeface="Calibri"/>
+                <a:ea typeface="Calibri"/>
+                <a:cs typeface="Calibri"/>
+                <a:sym typeface="Calibri"/>
+              </a:rPr>
+              <a:t>sentence, scheme_info</a:t>
+            </a:r>
             <a:br>
-              <a:rPr b="1" i="0" lang="en-US" sz="900" u="none" cap="none" strike="noStrike">
+              <a:rPr b="0" i="0" lang="en-US" sz="900" u="none" cap="none" strike="noStrike">
                 <a:solidFill>
                   <a:srgbClr val="FFFFFF"/>
                 </a:solidFill>
@@ -5953,7 +6032,7 @@
               <a:buNone/>
             </a:pPr>
             <a:r>
-              <a:rPr b="0" i="0" lang="en-US" sz="900" u="none" cap="none" strike="noStrike">
+              <a:rPr b="1" i="0" lang="en-US" sz="900" u="none" cap="none" strike="noStrike">
                 <a:solidFill>
                   <a:srgbClr val="FFFFFF"/>
                 </a:solidFill>
@@ -5962,53 +6041,8 @@
                 <a:cs typeface="Calibri"/>
                 <a:sym typeface="Calibri"/>
               </a:rPr>
-              <a:t>4 tests — basic, empty,</a:t>
-            </a:r>
-            <a:br>
-              <a:rPr b="0" i="0" lang="en-US" sz="900" u="none" cap="none" strike="noStrike">
-                <a:solidFill>
-                  <a:srgbClr val="FFFFFF"/>
-                </a:solidFill>
-                <a:latin typeface="Calibri"/>
-                <a:ea typeface="Calibri"/>
-                <a:cs typeface="Calibri"/>
-                <a:sym typeface="Calibri"/>
-              </a:rPr>
-            </a:br>
-            <a:r>
-              <a:rPr b="0" i="0" lang="en-US" sz="900" u="none" cap="none" strike="noStrike">
-                <a:solidFill>
-                  <a:srgbClr val="FFFFFF"/>
-                </a:solidFill>
-                <a:latin typeface="Calibri"/>
-                <a:ea typeface="Calibri"/>
-                <a:cs typeface="Calibri"/>
-                <a:sym typeface="Calibri"/>
-              </a:rPr>
-              <a:t>sentence, scheme_info</a:t>
-            </a:r>
-            <a:br>
-              <a:rPr b="0" i="0" lang="en-US" sz="900" u="none" cap="none" strike="noStrike">
-                <a:solidFill>
-                  <a:srgbClr val="FFFFFF"/>
-                </a:solidFill>
-                <a:latin typeface="Calibri"/>
-                <a:ea typeface="Calibri"/>
-                <a:cs typeface="Calibri"/>
-                <a:sym typeface="Calibri"/>
-              </a:rPr>
-            </a:br>
-            <a:br>
-              <a:rPr b="0" i="0" lang="en-US" sz="900" u="none" cap="none" strike="noStrike">
-                <a:solidFill>
-                  <a:srgbClr val="FFFFFF"/>
-                </a:solidFill>
-                <a:latin typeface="Calibri"/>
-                <a:ea typeface="Calibri"/>
-                <a:cs typeface="Calibri"/>
-                <a:sym typeface="Calibri"/>
-              </a:rPr>
-            </a:br>
+              <a:t>Utils</a:t>
+            </a:r>
             <a:endParaRPr b="0" i="0" sz="900" u="none" cap="none" strike="noStrike">
               <a:solidFill>
                 <a:schemeClr val="dk1"/>
@@ -6035,7 +6069,7 @@
               <a:buNone/>
             </a:pPr>
             <a:r>
-              <a:rPr b="1" i="0" lang="en-US" sz="900" u="none" cap="none" strike="noStrike">
+              <a:rPr b="0" i="0" lang="en-US" sz="900" u="none" cap="none" strike="noStrike">
                 <a:solidFill>
                   <a:srgbClr val="FFFFFF"/>
                 </a:solidFill>
@@ -6044,10 +6078,10 @@
                 <a:cs typeface="Calibri"/>
                 <a:sym typeface="Calibri"/>
               </a:rPr>
-              <a:t>Utils</a:t>
-            </a:r>
-            <a:br>
-              <a:rPr b="1" i="0" lang="en-US" sz="900" u="none" cap="none" strike="noStrike">
+              <a:t>5 tests — timestamp</a:t>
+            </a:r>
+            <a:r>
+              <a:rPr b="0" i="0" lang="en-US" sz="900" u="none" cap="none" strike="noStrike">
                 <a:solidFill>
                   <a:srgbClr val="FFFFFF"/>
                 </a:solidFill>
@@ -6056,10 +6090,35 @@
                 <a:cs typeface="Calibri"/>
                 <a:sym typeface="Calibri"/>
               </a:rPr>
-            </a:br>
+              <a:t>,</a:t>
+            </a:r>
+            <a:r>
+              <a:rPr lang="en-US" sz="900">
+                <a:solidFill>
+                  <a:schemeClr val="dk1"/>
+                </a:solidFill>
+                <a:latin typeface="Calibri"/>
+                <a:ea typeface="Calibri"/>
+                <a:cs typeface="Calibri"/>
+                <a:sym typeface="Calibri"/>
+              </a:rPr>
+              <a:t> </a:t>
+            </a:r>
+            <a:r>
+              <a:rPr b="0" i="0" lang="en-US" sz="900" u="none" cap="none" strike="noStrike">
+                <a:solidFill>
+                  <a:srgbClr val="FFFFFF"/>
+                </a:solidFill>
+                <a:latin typeface="Calibri"/>
+                <a:ea typeface="Calibri"/>
+                <a:cs typeface="Calibri"/>
+                <a:sym typeface="Calibri"/>
+              </a:rPr>
+              <a:t>audio validation, format</a:t>
+            </a:r>
             <a:endParaRPr b="0" i="0" sz="900" u="none" cap="none" strike="noStrike">
               <a:solidFill>
-                <a:schemeClr val="dk1"/>
+                <a:srgbClr val="FFFFFF"/>
               </a:solidFill>
               <a:latin typeface="Calibri"/>
               <a:ea typeface="Calibri"/>
@@ -6083,20 +6142,11 @@
               <a:buNone/>
             </a:pPr>
             <a:r>
-              <a:rPr b="0" i="0" lang="en-US" sz="900" u="none" cap="none" strike="noStrike">
-                <a:solidFill>
-                  <a:srgbClr val="FFFFFF"/>
-                </a:solidFill>
-                <a:latin typeface="Calibri"/>
-                <a:ea typeface="Calibri"/>
-                <a:cs typeface="Calibri"/>
-                <a:sym typeface="Calibri"/>
-              </a:rPr>
-              <a:t>5 tests — timestamp,</a:t>
-            </a:r>
-            <a:endParaRPr b="0" i="0" sz="900" u="none" cap="none" strike="noStrike">
+              <a:t/>
+            </a:r>
+            <a:endParaRPr sz="900">
               <a:solidFill>
-                <a:schemeClr val="dk1"/>
+                <a:srgbClr val="FFFFFF"/>
               </a:solidFill>
               <a:latin typeface="Calibri"/>
               <a:ea typeface="Calibri"/>
@@ -6105,7 +6155,7 @@
             </a:endParaRPr>
           </a:p>
           <a:p>
-            <a:pPr indent="0" lvl="0" marL="0" marR="0" rtl="0" algn="l">
+            <a:pPr indent="0" lvl="0" marL="0" rtl="0" algn="l">
               <a:spcBef>
                 <a:spcPts val="0"/>
               </a:spcBef>
@@ -6113,27 +6163,178 @@
                 <a:spcPts val="0"/>
               </a:spcAft>
               <a:buClr>
-                <a:srgbClr val="FFFFFF"/>
+                <a:schemeClr val="lt1"/>
               </a:buClr>
               <a:buSzPts val="900"/>
               <a:buFont typeface="Calibri"/>
               <a:buNone/>
             </a:pPr>
             <a:r>
-              <a:rPr b="0" i="0" lang="en-US" sz="900" u="none" cap="none" strike="noStrike">
-                <a:solidFill>
-                  <a:srgbClr val="FFFFFF"/>
-                </a:solidFill>
-                <a:latin typeface="Calibri"/>
-                <a:ea typeface="Calibri"/>
-                <a:cs typeface="Calibri"/>
-                <a:sym typeface="Calibri"/>
-              </a:rPr>
-              <a:t>audio validation, format</a:t>
-            </a:r>
-            <a:endParaRPr b="0" i="0" sz="900" u="none" cap="none" strike="noStrike">
+              <a:rPr b="1" lang="en-US" sz="900">
+                <a:solidFill>
+                  <a:schemeClr val="lt1"/>
+                </a:solidFill>
+                <a:latin typeface="Calibri"/>
+                <a:ea typeface="Calibri"/>
+                <a:cs typeface="Calibri"/>
+                <a:sym typeface="Calibri"/>
+              </a:rPr>
+              <a:t>Audio Splitting</a:t>
+            </a:r>
+            <a:endParaRPr b="1" sz="900">
               <a:solidFill>
+                <a:schemeClr val="lt1"/>
+              </a:solidFill>
+              <a:latin typeface="Calibri"/>
+              <a:ea typeface="Calibri"/>
+              <a:cs typeface="Calibri"/>
+              <a:sym typeface="Calibri"/>
+            </a:endParaRPr>
+          </a:p>
+          <a:p>
+            <a:pPr indent="0" lvl="0" marL="0" marR="76200" rtl="0" algn="l">
+              <a:lnSpc>
+                <a:spcPct val="115000"/>
+              </a:lnSpc>
+              <a:spcBef>
+                <a:spcPts val="0"/>
+              </a:spcBef>
+              <a:spcAft>
+                <a:spcPts val="0"/>
+              </a:spcAft>
+              <a:buClr>
                 <a:schemeClr val="dk1"/>
+              </a:buClr>
+              <a:buSzPts val="1100"/>
+              <a:buFont typeface="Arial"/>
+              <a:buNone/>
+            </a:pPr>
+            <a:r>
+              <a:rPr lang="en-US" sz="900">
+                <a:solidFill>
+                  <a:schemeClr val="lt1"/>
+                </a:solidFill>
+                <a:latin typeface="Calibri"/>
+                <a:ea typeface="Calibri"/>
+                <a:cs typeface="Calibri"/>
+                <a:sym typeface="Calibri"/>
+              </a:rPr>
+              <a:t>4 tests — short-file passthrough, 65s → 3 chunks, cleanup, safety belt</a:t>
+            </a:r>
+            <a:endParaRPr sz="900">
+              <a:solidFill>
+                <a:schemeClr val="lt1"/>
+              </a:solidFill>
+              <a:latin typeface="Calibri"/>
+              <a:ea typeface="Calibri"/>
+              <a:cs typeface="Calibri"/>
+              <a:sym typeface="Calibri"/>
+            </a:endParaRPr>
+          </a:p>
+          <a:p>
+            <a:pPr indent="0" lvl="0" marL="0" marR="76200" rtl="0" algn="l">
+              <a:lnSpc>
+                <a:spcPct val="115000"/>
+              </a:lnSpc>
+              <a:spcBef>
+                <a:spcPts val="0"/>
+              </a:spcBef>
+              <a:spcAft>
+                <a:spcPts val="0"/>
+              </a:spcAft>
+              <a:buClr>
+                <a:schemeClr val="dk1"/>
+              </a:buClr>
+              <a:buSzPts val="1100"/>
+              <a:buFont typeface="Arial"/>
+              <a:buNone/>
+            </a:pPr>
+            <a:r>
+              <a:t/>
+            </a:r>
+            <a:endParaRPr sz="900">
+              <a:solidFill>
+                <a:schemeClr val="lt1"/>
+              </a:solidFill>
+              <a:latin typeface="Calibri"/>
+              <a:ea typeface="Calibri"/>
+              <a:cs typeface="Calibri"/>
+              <a:sym typeface="Calibri"/>
+            </a:endParaRPr>
+          </a:p>
+          <a:p>
+            <a:pPr indent="0" lvl="0" marL="0" marR="76200" rtl="0" algn="l">
+              <a:lnSpc>
+                <a:spcPct val="115000"/>
+              </a:lnSpc>
+              <a:spcBef>
+                <a:spcPts val="0"/>
+              </a:spcBef>
+              <a:spcAft>
+                <a:spcPts val="0"/>
+              </a:spcAft>
+              <a:buClr>
+                <a:schemeClr val="dk1"/>
+              </a:buClr>
+              <a:buSzPts val="1100"/>
+              <a:buFont typeface="Arial"/>
+              <a:buNone/>
+            </a:pPr>
+            <a:r>
+              <a:rPr b="1" lang="en-US" sz="900">
+                <a:solidFill>
+                  <a:schemeClr val="lt1"/>
+                </a:solidFill>
+                <a:latin typeface="Calibri"/>
+                <a:ea typeface="Calibri"/>
+                <a:cs typeface="Calibri"/>
+                <a:sym typeface="Calibri"/>
+              </a:rPr>
+              <a:t>Chunk Batching    </a:t>
+            </a:r>
+            <a:endParaRPr b="1" sz="900">
+              <a:solidFill>
+                <a:schemeClr val="lt1"/>
+              </a:solidFill>
+              <a:latin typeface="Calibri"/>
+              <a:ea typeface="Calibri"/>
+              <a:cs typeface="Calibri"/>
+              <a:sym typeface="Calibri"/>
+            </a:endParaRPr>
+          </a:p>
+          <a:p>
+            <a:pPr indent="0" lvl="0" marL="0" marR="76200" rtl="0" algn="l">
+              <a:lnSpc>
+                <a:spcPct val="115000"/>
+              </a:lnSpc>
+              <a:spcBef>
+                <a:spcPts val="0"/>
+              </a:spcBef>
+              <a:spcAft>
+                <a:spcPts val="0"/>
+              </a:spcAft>
+              <a:buClr>
+                <a:schemeClr val="dk1"/>
+              </a:buClr>
+              <a:buSzPts val="1100"/>
+              <a:buFont typeface="Arial"/>
+              <a:buNone/>
+            </a:pPr>
+            <a:r>
+              <a:rPr lang="en-US" sz="900">
+                <a:solidFill>
+                  <a:schemeClr val="lt1"/>
+                </a:solidFill>
+                <a:latin typeface="Calibri"/>
+                <a:ea typeface="Calibri"/>
+                <a:cs typeface="Calibri"/>
+                <a:sym typeface="Calibri"/>
+              </a:rPr>
+              <a:t>1 test  — N &gt; maxsize batched correctly (no truncation)</a:t>
+            </a:r>
+            <a:endParaRPr sz="900">
+              <a:solidFill>
+                <a:schemeClr val="lt1"/>
               </a:solidFill>
               <a:latin typeface="Calibri"/>
               <a:ea typeface="Calibri"/>
@@ -7131,7 +7332,7 @@
               <a:buNone/>
             </a:pPr>
             <a:r>
-              <a:rPr b="1" i="0" lang="en-US" sz="1000" u="none" cap="none" strike="noStrike">
+              <a:rPr b="1" lang="en-US" sz="1000">
                 <a:solidFill>
                   <a:srgbClr val="1A2A3A"/>
                 </a:solidFill>
@@ -7140,10 +7341,10 @@
                 <a:cs typeface="Calibri"/>
                 <a:sym typeface="Calibri"/>
               </a:rPr>
-              <a:t>Whole-file inference</a:t>
-            </a:r>
-            <a:r>
-              <a:rPr b="0" i="0" lang="en-US" sz="1000" u="none" cap="none" strike="noStrike">
+              <a:t>Fixed-duration chunks without overlap</a:t>
+            </a:r>
+            <a:r>
+              <a:rPr lang="en-US" sz="1000">
                 <a:solidFill>
                   <a:srgbClr val="1A2A3A"/>
                 </a:solidFill>
@@ -7152,22 +7353,11 @@
                 <a:cs typeface="Calibri"/>
                 <a:sym typeface="Calibri"/>
               </a:rPr>
-              <a:t> — buffer queues file paths, not raw PCM</a:t>
-            </a:r>
-            <a:br>
-              <a:rPr b="0" i="0" lang="en-US" sz="1000" u="none" cap="none" strike="noStrike">
-                <a:solidFill>
-                  <a:srgbClr val="1A2A3A"/>
-                </a:solidFill>
-                <a:latin typeface="Calibri"/>
-                <a:ea typeface="Calibri"/>
-                <a:cs typeface="Calibri"/>
-                <a:sym typeface="Calibri"/>
-              </a:rPr>
-            </a:br>
-            <a:endParaRPr b="0" i="0" sz="1000" u="none" cap="none" strike="noStrike">
+              <a:t> — minor seam artifacts possible at chunk boundaries</a:t>
+            </a:r>
+            <a:endParaRPr sz="1000">
               <a:solidFill>
-                <a:schemeClr val="dk1"/>
+                <a:srgbClr val="1A2A3A"/>
               </a:solidFill>
               <a:latin typeface="Calibri"/>
               <a:ea typeface="Calibri"/>
@@ -7191,6 +7381,34 @@
               <a:buNone/>
             </a:pPr>
             <a:r>
+              <a:t/>
+            </a:r>
+            <a:endParaRPr sz="1000">
+              <a:solidFill>
+                <a:srgbClr val="1A2A3A"/>
+              </a:solidFill>
+              <a:latin typeface="Calibri"/>
+              <a:ea typeface="Calibri"/>
+              <a:cs typeface="Calibri"/>
+              <a:sym typeface="Calibri"/>
+            </a:endParaRPr>
+          </a:p>
+          <a:p>
+            <a:pPr indent="0" lvl="0" marL="0" marR="0" rtl="0" algn="l">
+              <a:spcBef>
+                <a:spcPts val="0"/>
+              </a:spcBef>
+              <a:spcAft>
+                <a:spcPts val="0"/>
+              </a:spcAft>
+              <a:buClr>
+                <a:srgbClr val="1A2A3A"/>
+              </a:buClr>
+              <a:buSzPts val="1000"/>
+              <a:buFont typeface="Calibri"/>
+              <a:buNone/>
+            </a:pPr>
+            <a:r>
               <a:rPr b="1" i="0" lang="en-US" sz="1000" u="none" cap="none" strike="noStrike">
                 <a:solidFill>
                   <a:srgbClr val="1A2A3A"/>
@@ -7200,7 +7418,31 @@
                 <a:cs typeface="Calibri"/>
                 <a:sym typeface="Calibri"/>
               </a:rPr>
-              <a:t>Romanization fixed to HK scheme</a:t>
+              <a:t>Romanization fixed to </a:t>
+            </a:r>
+            <a:r>
+              <a:rPr b="1" lang="en-US" sz="1000">
+                <a:solidFill>
+                  <a:srgbClr val="1A2A3A"/>
+                </a:solidFill>
+                <a:latin typeface="Calibri"/>
+                <a:ea typeface="Calibri"/>
+                <a:cs typeface="Calibri"/>
+                <a:sym typeface="Calibri"/>
+              </a:rPr>
+              <a:t>custom Tamil-aware ASCII </a:t>
+            </a:r>
+            <a:r>
+              <a:rPr b="1" i="0" lang="en-US" sz="1000" u="none" cap="none" strike="noStrike">
+                <a:solidFill>
+                  <a:srgbClr val="1A2A3A"/>
+                </a:solidFill>
+                <a:latin typeface="Calibri"/>
+                <a:ea typeface="Calibri"/>
+                <a:cs typeface="Calibri"/>
+                <a:sym typeface="Calibri"/>
+              </a:rPr>
+              <a:t>scheme</a:t>
             </a:r>
             <a:r>
               <a:rPr b="0" i="0" lang="en-US" sz="1000" u="none" cap="none" strike="noStrike">
@@ -8168,7 +8410,31 @@
                 <a:cs typeface="Calibri"/>
                 <a:sym typeface="Calibri"/>
               </a:rPr>
-              <a:t>Full ASR pipeline deployed — Whisper-medium + indic-transliteration + Gradio + Docker port 7860</a:t>
+              <a:t>Full ASR pipeline deployed — Whisper-medium + </a:t>
+            </a:r>
+            <a:r>
+              <a:rPr lang="en-US" sz="1364">
+                <a:solidFill>
+                  <a:srgbClr val="FFFFFF"/>
+                </a:solidFill>
+                <a:latin typeface="Calibri"/>
+                <a:ea typeface="Calibri"/>
+                <a:cs typeface="Calibri"/>
+                <a:sym typeface="Calibri"/>
+              </a:rPr>
+              <a:t>custom Tamil ASCII romanizer</a:t>
+            </a:r>
+            <a:r>
+              <a:rPr b="0" i="0" lang="en-US" sz="1364" u="none" cap="none" strike="noStrike">
+                <a:solidFill>
+                  <a:srgbClr val="FFFFFF"/>
+                </a:solidFill>
+                <a:latin typeface="Calibri"/>
+                <a:ea typeface="Calibri"/>
+                <a:cs typeface="Calibri"/>
+                <a:sym typeface="Calibri"/>
+              </a:rPr>
+              <a:t> + Gradio + Docker port 7860</a:t>
             </a:r>
             <a:endParaRPr b="0" i="0" sz="1364" u="none" cap="none" strike="noStrike">
               <a:solidFill>
@@ -8285,6 +8551,18 @@
               <a:buNone/>
             </a:pPr>
             <a:r>
+              <a:rPr lang="en-US" sz="1364">
+                <a:solidFill>
+                  <a:srgbClr val="FFFFFF"/>
+                </a:solidFill>
+                <a:latin typeface="Calibri"/>
+                <a:ea typeface="Calibri"/>
+                <a:cs typeface="Calibri"/>
+                <a:sym typeface="Calibri"/>
+              </a:rPr>
+              <a:t>20</a:t>
+            </a:r>
+            <a:r>
               <a:rPr b="0" i="0" lang="en-US" sz="1364" u="none" cap="none" strike="noStrike">
                 <a:solidFill>
                   <a:srgbClr val="FFFFFF"/>
@@ -8294,7 +8572,31 @@
                 <a:cs typeface="Calibri"/>
                 <a:sym typeface="Calibri"/>
               </a:rPr>
-              <a:t>15/15 unit tests passed — BufferManager, TransliterationPipeline, and Utils fully validated</a:t>
+              <a:t>/</a:t>
+            </a:r>
+            <a:r>
+              <a:rPr lang="en-US" sz="1364">
+                <a:solidFill>
+                  <a:srgbClr val="FFFFFF"/>
+                </a:solidFill>
+                <a:latin typeface="Calibri"/>
+                <a:ea typeface="Calibri"/>
+                <a:cs typeface="Calibri"/>
+                <a:sym typeface="Calibri"/>
+              </a:rPr>
+              <a:t>20</a:t>
+            </a:r>
+            <a:r>
+              <a:rPr b="0" i="0" lang="en-US" sz="1364" u="none" cap="none" strike="noStrike">
+                <a:solidFill>
+                  <a:srgbClr val="FFFFFF"/>
+                </a:solidFill>
+                <a:latin typeface="Calibri"/>
+                <a:ea typeface="Calibri"/>
+                <a:cs typeface="Calibri"/>
+                <a:sym typeface="Calibri"/>
+              </a:rPr>
+              <a:t> unit tests passed — BufferManager, TransliterationPipeline, Utils, AudioSplitting, ChunkBatching fully validated</a:t>
             </a:r>
             <a:endParaRPr b="0" i="0" sz="1364" u="none" cap="none" strike="noStrike">
               <a:solidFill>
@@ -9001,20 +9303,9 @@
                 <a:sym typeface="Calibri"/>
               </a:rPr>
             </a:br>
-            <a:br>
-              <a:rPr b="0" i="0" lang="en-US" sz="1100" u="none" cap="none" strike="noStrike">
-                <a:solidFill>
-                  <a:srgbClr val="1A2A3A"/>
-                </a:solidFill>
-                <a:latin typeface="Calibri"/>
-                <a:ea typeface="Calibri"/>
-                <a:cs typeface="Calibri"/>
-                <a:sym typeface="Calibri"/>
-              </a:rPr>
-            </a:br>
-            <a:endParaRPr b="0" i="0" sz="1100" u="none" cap="none" strike="noStrike">
+            <a:endParaRPr sz="1100">
               <a:solidFill>
-                <a:schemeClr val="dk1"/>
+                <a:srgbClr val="1A2A3A"/>
               </a:solidFill>
               <a:latin typeface="Calibri"/>
               <a:ea typeface="Calibri"/>
@@ -9596,6 +9887,83 @@
               <a:buNone/>
             </a:pPr>
             <a:r>
+              <a:rPr b="1" lang="en-US" sz="1100">
+                <a:solidFill>
+                  <a:srgbClr val="1A2A3A"/>
+                </a:solidFill>
+                <a:latin typeface="Calibri"/>
+                <a:ea typeface="Calibri"/>
+                <a:cs typeface="Calibri"/>
+                <a:sym typeface="Calibri"/>
+              </a:rPr>
+              <a:t>Buffer: </a:t>
+            </a:r>
+            <a:r>
+              <a:rPr lang="en-US" sz="1100">
+                <a:solidFill>
+                  <a:srgbClr val="1A2A3A"/>
+                </a:solidFill>
+                <a:latin typeface="Calibri"/>
+                <a:ea typeface="Calibri"/>
+                <a:cs typeface="Calibri"/>
+                <a:sym typeface="Calibri"/>
+              </a:rPr>
+              <a:t>chunked (≤30 s) + queue.Queue(maxsize=10), bounded batches</a:t>
+            </a:r>
+            <a:endParaRPr sz="1100">
+              <a:solidFill>
+                <a:srgbClr val="1A2A3A"/>
+              </a:solidFill>
+              <a:latin typeface="Calibri"/>
+              <a:ea typeface="Calibri"/>
+              <a:cs typeface="Calibri"/>
+              <a:sym typeface="Calibri"/>
+            </a:endParaRPr>
+          </a:p>
+          <a:p>
+            <a:pPr indent="0" lvl="0" marL="0" marR="0" rtl="0" algn="l">
+              <a:spcBef>
+                <a:spcPts val="0"/>
+              </a:spcBef>
+              <a:spcAft>
+                <a:spcPts val="0"/>
+              </a:spcAft>
+              <a:buClr>
+                <a:srgbClr val="1A2A3A"/>
+              </a:buClr>
+              <a:buSzPts val="1100"/>
+              <a:buFont typeface="Calibri"/>
+              <a:buNone/>
+            </a:pPr>
+            <a:r>
+              <a:t/>
+            </a:r>
+            <a:endParaRPr sz="1100">
+              <a:solidFill>
+                <a:srgbClr val="1A2A3A"/>
+              </a:solidFill>
+              <a:latin typeface="Calibri"/>
+              <a:ea typeface="Calibri"/>
+              <a:cs typeface="Calibri"/>
+              <a:sym typeface="Calibri"/>
+            </a:endParaRPr>
+          </a:p>
+          <a:p>
+            <a:pPr indent="0" lvl="0" marL="0" marR="0" rtl="0" algn="l">
+              <a:spcBef>
+                <a:spcPts val="0"/>
+              </a:spcBef>
+              <a:spcAft>
+                <a:spcPts val="0"/>
+              </a:spcAft>
+              <a:buClr>
+                <a:srgbClr val="1A2A3A"/>
+              </a:buClr>
+              <a:buSzPts val="1100"/>
+              <a:buFont typeface="Calibri"/>
+              <a:buNone/>
+            </a:pPr>
+            <a:r>
               <a:rPr b="1" i="0" lang="en-US" sz="1100" u="none" cap="none" strike="noStrike">
                 <a:solidFill>
                   <a:srgbClr val="1A2A3A"/>
@@ -9605,7 +9973,7 @@
                 <a:cs typeface="Calibri"/>
                 <a:sym typeface="Calibri"/>
               </a:rPr>
-              <a:t>Buffer: </a:t>
+              <a:t>Deploy: </a:t>
             </a:r>
             <a:r>
               <a:rPr b="0" i="0" lang="en-US" sz="1100" u="none" cap="none" strike="noStrike">
@@ -9617,7 +9985,7 @@
                 <a:cs typeface="Calibri"/>
                 <a:sym typeface="Calibri"/>
               </a:rPr>
-              <a:t>queue.Queue(maxsize=10)</a:t>
+              <a:t>Docker + docker-compose</a:t>
             </a:r>
             <a:br>
               <a:rPr b="0" i="0" lang="en-US" sz="1100" u="none" cap="none" strike="noStrike">
@@ -9665,7 +10033,19 @@
                 <a:cs typeface="Calibri"/>
                 <a:sym typeface="Calibri"/>
               </a:rPr>
-              <a:t>Deploy: </a:t>
+              <a:t>Tests: </a:t>
+            </a:r>
+            <a:r>
+              <a:rPr lang="en-US" sz="1100">
+                <a:solidFill>
+                  <a:srgbClr val="1A2A3A"/>
+                </a:solidFill>
+                <a:latin typeface="Calibri"/>
+                <a:ea typeface="Calibri"/>
+                <a:cs typeface="Calibri"/>
+                <a:sym typeface="Calibri"/>
+              </a:rPr>
+              <a:t>20</a:t>
             </a:r>
             <a:r>
               <a:rPr b="0" i="0" lang="en-US" sz="1100" u="none" cap="none" strike="noStrike">
@@ -9677,9 +10057,21 @@
                 <a:cs typeface="Calibri"/>
                 <a:sym typeface="Calibri"/>
               </a:rPr>
-              <a:t>Docker + docker-compose</a:t>
-            </a:r>
-            <a:br>
+              <a:t>/</a:t>
+            </a:r>
+            <a:r>
+              <a:rPr lang="en-US" sz="1100">
+                <a:solidFill>
+                  <a:srgbClr val="1A2A3A"/>
+                </a:solidFill>
+                <a:latin typeface="Calibri"/>
+                <a:ea typeface="Calibri"/>
+                <a:cs typeface="Calibri"/>
+                <a:sym typeface="Calibri"/>
+              </a:rPr>
+              <a:t>20</a:t>
+            </a:r>
+            <a:r>
               <a:rPr b="0" i="0" lang="en-US" sz="1100" u="none" cap="none" strike="noStrike">
                 <a:solidFill>
                   <a:srgbClr val="1A2A3A"/>
@@ -9689,66 +10081,7 @@
                 <a:cs typeface="Calibri"/>
                 <a:sym typeface="Calibri"/>
               </a:rPr>
-            </a:br>
-            <a:br>
-              <a:rPr b="0" i="0" lang="en-US" sz="1100" u="none" cap="none" strike="noStrike">
-                <a:solidFill>
-                  <a:srgbClr val="1A2A3A"/>
-                </a:solidFill>
-                <a:latin typeface="Calibri"/>
-                <a:ea typeface="Calibri"/>
-                <a:cs typeface="Calibri"/>
-                <a:sym typeface="Calibri"/>
-              </a:rPr>
-            </a:br>
-            <a:endParaRPr b="0" i="0" sz="1100" u="none" cap="none" strike="noStrike">
-              <a:solidFill>
-                <a:schemeClr val="dk1"/>
-              </a:solidFill>
-              <a:latin typeface="Calibri"/>
-              <a:ea typeface="Calibri"/>
-              <a:cs typeface="Calibri"/>
-              <a:sym typeface="Calibri"/>
-            </a:endParaRPr>
-          </a:p>
-          <a:p>
-            <a:pPr indent="0" lvl="0" marL="0" marR="0" rtl="0" algn="l">
-              <a:spcBef>
-                <a:spcPts val="0"/>
-              </a:spcBef>
-              <a:spcAft>
-                <a:spcPts val="0"/>
-              </a:spcAft>
-              <a:buClr>
-                <a:srgbClr val="1A2A3A"/>
-              </a:buClr>
-              <a:buSzPts val="1100"/>
-              <a:buFont typeface="Calibri"/>
-              <a:buNone/>
-            </a:pPr>
-            <a:r>
-              <a:rPr b="1" i="0" lang="en-US" sz="1100" u="none" cap="none" strike="noStrike">
-                <a:solidFill>
-                  <a:srgbClr val="1A2A3A"/>
-                </a:solidFill>
-                <a:latin typeface="Calibri"/>
-                <a:ea typeface="Calibri"/>
-                <a:cs typeface="Calibri"/>
-                <a:sym typeface="Calibri"/>
-              </a:rPr>
-              <a:t>Tests: </a:t>
-            </a:r>
-            <a:r>
-              <a:rPr b="0" i="0" lang="en-US" sz="1100" u="none" cap="none" strike="noStrike">
-                <a:solidFill>
-                  <a:srgbClr val="1A2A3A"/>
-                </a:solidFill>
-                <a:latin typeface="Calibri"/>
-                <a:ea typeface="Calibri"/>
-                <a:cs typeface="Calibri"/>
-                <a:sym typeface="Calibri"/>
-              </a:rPr>
-              <a:t>15/15 passed</a:t>
+              <a:t> passed</a:t>
             </a:r>
             <a:endParaRPr b="0" i="0" sz="1100" u="none" cap="none" strike="noStrike">
               <a:solidFill>
@@ -10460,7 +10793,7 @@
             <a:tbl>
               <a:tblPr>
                 <a:noFill/>
-                <a:tableStyleId>{15485537-3454-4B1E-8CA2-5F550A3058AC}</a:tableStyleId>
+                <a:tableStyleId>{CFCA71AA-75EC-4A87-9C37-5847503978CC}</a:tableStyleId>
               </a:tblPr>
               <a:tblGrid>
                 <a:gridCol w="1188725"/>
@@ -13325,7 +13658,7 @@
         </p:nvSpPr>
         <p:spPr>
           <a:xfrm>
-            <a:off x="457256" y="917114"/>
+            <a:off x="457256" y="903269"/>
             <a:ext cx="2275800" cy="2173200"/>
           </a:xfrm>
           <a:prstGeom prst="rect">
@@ -13374,7 +13707,7 @@
         </p:nvSpPr>
         <p:spPr>
           <a:xfrm>
-            <a:off x="541548" y="997605"/>
+            <a:off x="541548" y="983760"/>
             <a:ext cx="2107200" cy="265500"/>
           </a:xfrm>
           <a:prstGeom prst="rect">
@@ -13437,7 +13770,7 @@
         </p:nvSpPr>
         <p:spPr>
           <a:xfrm>
-            <a:off x="541548" y="1279322"/>
+            <a:off x="541548" y="1265477"/>
             <a:ext cx="2107200" cy="225300"/>
           </a:xfrm>
           <a:prstGeom prst="rect">
@@ -13500,7 +13833,7 @@
         </p:nvSpPr>
         <p:spPr>
           <a:xfrm>
-            <a:off x="541548" y="1496647"/>
+            <a:off x="541548" y="1482802"/>
             <a:ext cx="2107200" cy="523200"/>
           </a:xfrm>
           <a:prstGeom prst="rect">
@@ -13563,7 +13896,7 @@
         </p:nvSpPr>
         <p:spPr>
           <a:xfrm>
-            <a:off x="541548" y="2027885"/>
+            <a:off x="541548" y="2014040"/>
             <a:ext cx="2107200" cy="184800"/>
           </a:xfrm>
           <a:prstGeom prst="rect">
@@ -13626,7 +13959,7 @@
         </p:nvSpPr>
         <p:spPr>
           <a:xfrm>
-            <a:off x="541548" y="2245210"/>
+            <a:off x="541548" y="2231365"/>
             <a:ext cx="2107200" cy="442500"/>
           </a:xfrm>
           <a:prstGeom prst="rect">
@@ -13761,7 +14094,7 @@
         </p:nvSpPr>
         <p:spPr>
           <a:xfrm>
-            <a:off x="3585596" y="917173"/>
+            <a:off x="3585596" y="903327"/>
             <a:ext cx="5101200" cy="2173200"/>
           </a:xfrm>
           <a:prstGeom prst="rect">
@@ -13810,7 +14143,7 @@
         </p:nvSpPr>
         <p:spPr>
           <a:xfrm>
-            <a:off x="3677046" y="990323"/>
+            <a:off x="3677046" y="976477"/>
             <a:ext cx="4917300" cy="301800"/>
           </a:xfrm>
           <a:prstGeom prst="rect">
@@ -13872,7 +14205,7 @@
           <p:nvPr/>
         </p:nvGraphicFramePr>
         <p:xfrm>
-          <a:off x="3677046" y="1346941"/>
+          <a:off x="3677046" y="1333095"/>
           <a:ext cx="3000000" cy="3000000"/>
         </p:xfrm>
         <a:graphic>
@@ -13880,7 +14213,7 @@
             <a:tbl>
               <a:tblPr>
                 <a:noFill/>
-                <a:tableStyleId>{15485537-3454-4B1E-8CA2-5F550A3058AC}</a:tableStyleId>
+                <a:tableStyleId>{CFCA71AA-75EC-4A87-9C37-5847503978CC}</a:tableStyleId>
               </a:tblPr>
               <a:tblGrid>
                 <a:gridCol w="1583525"/>
@@ -15178,7 +15511,7 @@
         </p:blipFill>
         <p:spPr>
           <a:xfrm>
-            <a:off x="457256" y="3285075"/>
+            <a:off x="457256" y="3264307"/>
             <a:ext cx="3704749" cy="1646626"/>
           </a:xfrm>
           <a:prstGeom prst="rect">
@@ -15187,7 +15520,7 @@
           <a:noFill/>
           <a:ln cap="flat" cmpd="sng" w="9525">
             <a:solidFill>
-              <a:srgbClr val="000000"/>
+              <a:srgbClr val="C8DCE8"/>
             </a:solidFill>
             <a:prstDash val="solid"/>
             <a:round/>
@@ -15204,7 +15537,7 @@
         </p:nvSpPr>
         <p:spPr>
           <a:xfrm>
-            <a:off x="457206" y="4936725"/>
+            <a:off x="457206" y="4915957"/>
             <a:ext cx="3704700" cy="183000"/>
           </a:xfrm>
           <a:prstGeom prst="rect">
@@ -15267,7 +15600,7 @@
         </p:nvSpPr>
         <p:spPr>
           <a:xfrm>
-            <a:off x="4572000" y="3285150"/>
+            <a:off x="4572000" y="3264382"/>
             <a:ext cx="4114800" cy="1646700"/>
           </a:xfrm>
           <a:prstGeom prst="rect">
@@ -15316,7 +15649,7 @@
         </p:nvSpPr>
         <p:spPr>
           <a:xfrm>
-            <a:off x="4663437" y="3337463"/>
+            <a:off x="4663437" y="3316695"/>
             <a:ext cx="3931800" cy="183000"/>
           </a:xfrm>
           <a:prstGeom prst="rect">
@@ -15378,7 +15711,7 @@
           <p:nvPr/>
         </p:nvGraphicFramePr>
         <p:xfrm>
-          <a:off x="4760359" y="3588269"/>
+          <a:off x="4760359" y="3546734"/>
           <a:ext cx="3000000" cy="3000000"/>
         </p:xfrm>
         <a:graphic>
@@ -15386,7 +15719,7 @@
             <a:tbl>
               <a:tblPr>
                 <a:noFill/>
-                <a:tableStyleId>{15485537-3454-4B1E-8CA2-5F550A3058AC}</a:tableStyleId>
+                <a:tableStyleId>{CFCA71AA-75EC-4A87-9C37-5847503978CC}</a:tableStyleId>
               </a:tblPr>
               <a:tblGrid>
                 <a:gridCol w="1303975"/>
@@ -19868,21 +20201,22 @@
       </p:sp>
       <p:pic>
         <p:nvPicPr>
-          <p:cNvPr descr="preencoded.png" id="158" name="Google Shape;158;p8"/>
+          <p:cNvPr id="158" name="Google Shape;158;p8" title="system_architecture.png"/>
           <p:cNvPicPr preferRelativeResize="0"/>
           <p:nvPr/>
         </p:nvPicPr>
-        <p:blipFill rotWithShape="1">
+        <p:blipFill>
           <a:blip r:embed="rId3">
             <a:alphaModFix/>
           </a:blip>
-          <a:srcRect b="0" l="0" r="0" t="0"/>
-          <a:stretch/>
+          <a:stretch>
+            <a:fillRect/>
+          </a:stretch>
         </p:blipFill>
         <p:spPr>
           <a:xfrm>
-            <a:off x="764625" y="939350"/>
-            <a:ext cx="7614751" cy="3974226"/>
+            <a:off x="1053863" y="874795"/>
+            <a:ext cx="7036274" cy="4116324"/>
           </a:xfrm>
           <a:prstGeom prst="rect">
             <a:avLst/>
@@ -20039,21 +20373,22 @@
       </p:sp>
       <p:pic>
         <p:nvPicPr>
-          <p:cNvPr descr="preencoded.png" id="166" name="Google Shape;166;p9"/>
+          <p:cNvPr id="166" name="Google Shape;166;p9" title="buffer_flow_diagram.png"/>
           <p:cNvPicPr preferRelativeResize="0"/>
           <p:nvPr/>
         </p:nvPicPr>
-        <p:blipFill rotWithShape="1">
+        <p:blipFill>
           <a:blip r:embed="rId3">
             <a:alphaModFix/>
           </a:blip>
-          <a:srcRect b="0" l="0" r="0" t="0"/>
-          <a:stretch/>
+          <a:stretch>
+            <a:fillRect/>
+          </a:stretch>
         </p:blipFill>
         <p:spPr>
           <a:xfrm>
-            <a:off x="656200" y="926225"/>
-            <a:ext cx="7831626" cy="3993925"/>
+            <a:off x="511887" y="874775"/>
+            <a:ext cx="8120225" cy="4116325"/>
           </a:xfrm>
           <a:prstGeom prst="rect">
             <a:avLst/>

</xml_diff>